<commit_message>
Mark briefing docs as Lockheed Martin Proprietary
Byline is Thomas Rathbun, PhD. Proprietary line is in every header
and footer of the progress report, block guide, and slide decks.
</commit_message>
<xml_diff>
--- a/artifacts/Business_Problem_Statement.pptx
+++ b/artifacts/Business_Problem_Statement.pptx
@@ -947,6 +947,84 @@
         </p:nvSpPr>
         <p:spPr>
           <a:xfrm>
+            <a:off x="411480" y="54864"/>
+            <a:ext cx="8321040" cy="182880"/>
+          </a:xfrm>
+          <a:prstGeom prst="rect">
+            <a:avLst/>
+          </a:prstGeom>
+          <a:noFill/>
+          <a:ln/>
+        </p:spPr>
+        <p:txBody>
+          <a:bodyPr wrap="square" lIns="0" tIns="0" rIns="0" bIns="0" rtlCol="0" anchor="ctr"/>
+          <a:lstStyle/>
+          <a:p>
+            <a:pPr indent="0" marL="0">
+              <a:buNone/>
+            </a:pPr>
+            <a:r>
+              <a:rPr lang="en-US" sz="900" b="1" dirty="0">
+                <a:solidFill>
+                  <a:srgbClr val="FECACA"/>
+                </a:solidFill>
+                <a:latin typeface="Calibri" pitchFamily="34" charset="0"/>
+                <a:ea typeface="Calibri" pitchFamily="34" charset="-122"/>
+                <a:cs typeface="Calibri" pitchFamily="34" charset="-120"/>
+              </a:rPr>
+              <a:t>LOCKHEED MARTIN PROPRIETARY INFORMATION</a:t>
+            </a:r>
+            <a:endParaRPr lang="en-US" sz="900" dirty="0"/>
+          </a:p>
+        </p:txBody>
+      </p:sp>
+      <p:sp>
+        <p:nvSpPr>
+          <p:cNvPr id="5" name="Text 3"/>
+          <p:cNvSpPr/>
+          <p:nvPr/>
+        </p:nvSpPr>
+        <p:spPr>
+          <a:xfrm>
+            <a:off x="411480" y="4919472"/>
+            <a:ext cx="8321040" cy="182880"/>
+          </a:xfrm>
+          <a:prstGeom prst="rect">
+            <a:avLst/>
+          </a:prstGeom>
+          <a:noFill/>
+          <a:ln/>
+        </p:spPr>
+        <p:txBody>
+          <a:bodyPr wrap="square" lIns="0" tIns="0" rIns="0" bIns="0" rtlCol="0" anchor="ctr"/>
+          <a:lstStyle/>
+          <a:p>
+            <a:pPr indent="0" marL="0">
+              <a:buNone/>
+            </a:pPr>
+            <a:r>
+              <a:rPr lang="en-US" sz="900" dirty="0">
+                <a:solidFill>
+                  <a:srgbClr val="94A3B8"/>
+                </a:solidFill>
+                <a:latin typeface="Calibri" pitchFamily="34" charset="0"/>
+                <a:ea typeface="Calibri" pitchFamily="34" charset="-122"/>
+                <a:cs typeface="Calibri" pitchFamily="34" charset="-120"/>
+              </a:rPr>
+              <a:t>Thomas Rathbun, PhD  ·  LOCKHEED MARTIN PROPRIETARY INFORMATION</a:t>
+            </a:r>
+            <a:endParaRPr lang="en-US" sz="900" dirty="0"/>
+          </a:p>
+        </p:txBody>
+      </p:sp>
+      <p:sp>
+        <p:nvSpPr>
+          <p:cNvPr id="6" name="Text 4"/>
+          <p:cNvSpPr/>
+          <p:nvPr/>
+        </p:nvSpPr>
+        <p:spPr>
+          <a:xfrm>
             <a:off x="411480" y="502920"/>
             <a:ext cx="8321040" cy="502920"/>
           </a:xfrm>
@@ -980,7 +1058,7 @@
       </p:sp>
       <p:sp>
         <p:nvSpPr>
-          <p:cNvPr id="5" name="Shape 3"/>
+          <p:cNvPr id="7" name="Shape 5"/>
           <p:cNvSpPr/>
           <p:nvPr/>
         </p:nvSpPr>
@@ -1007,7 +1085,7 @@
       </p:sp>
       <p:sp>
         <p:nvSpPr>
-          <p:cNvPr id="6" name="Text 4"/>
+          <p:cNvPr id="8" name="Text 6"/>
           <p:cNvSpPr/>
           <p:nvPr/>
         </p:nvSpPr>
@@ -1046,7 +1124,7 @@
       </p:sp>
       <p:sp>
         <p:nvSpPr>
-          <p:cNvPr id="7" name="Shape 5"/>
+          <p:cNvPr id="9" name="Shape 7"/>
           <p:cNvSpPr/>
           <p:nvPr/>
         </p:nvSpPr>
@@ -1073,7 +1151,7 @@
       </p:sp>
       <p:sp>
         <p:nvSpPr>
-          <p:cNvPr id="8" name="Shape 6"/>
+          <p:cNvPr id="10" name="Shape 8"/>
           <p:cNvSpPr/>
           <p:nvPr/>
         </p:nvSpPr>
@@ -1098,7 +1176,7 @@
       </p:sp>
       <p:sp>
         <p:nvSpPr>
-          <p:cNvPr id="9" name="Text 7"/>
+          <p:cNvPr id="11" name="Text 9"/>
           <p:cNvSpPr/>
           <p:nvPr/>
         </p:nvSpPr>
@@ -1137,7 +1215,7 @@
       </p:sp>
       <p:sp>
         <p:nvSpPr>
-          <p:cNvPr id="10" name="Text 8"/>
+          <p:cNvPr id="12" name="Text 10"/>
           <p:cNvSpPr/>
           <p:nvPr/>
         </p:nvSpPr>
@@ -1176,7 +1254,7 @@
       </p:sp>
       <p:sp>
         <p:nvSpPr>
-          <p:cNvPr id="11" name="Text 9"/>
+          <p:cNvPr id="13" name="Text 11"/>
           <p:cNvSpPr/>
           <p:nvPr/>
         </p:nvSpPr>
@@ -1215,7 +1293,7 @@
       </p:sp>
       <p:sp>
         <p:nvSpPr>
-          <p:cNvPr id="12" name="Shape 10"/>
+          <p:cNvPr id="14" name="Shape 12"/>
           <p:cNvSpPr/>
           <p:nvPr/>
         </p:nvSpPr>
@@ -1242,7 +1320,7 @@
       </p:sp>
       <p:sp>
         <p:nvSpPr>
-          <p:cNvPr id="13" name="Shape 11"/>
+          <p:cNvPr id="15" name="Shape 13"/>
           <p:cNvSpPr/>
           <p:nvPr/>
         </p:nvSpPr>
@@ -1267,7 +1345,7 @@
       </p:sp>
       <p:sp>
         <p:nvSpPr>
-          <p:cNvPr id="14" name="Text 12"/>
+          <p:cNvPr id="16" name="Text 14"/>
           <p:cNvSpPr/>
           <p:nvPr/>
         </p:nvSpPr>
@@ -1306,7 +1384,7 @@
       </p:sp>
       <p:sp>
         <p:nvSpPr>
-          <p:cNvPr id="15" name="Text 13"/>
+          <p:cNvPr id="17" name="Text 15"/>
           <p:cNvSpPr/>
           <p:nvPr/>
         </p:nvSpPr>
@@ -1345,7 +1423,7 @@
       </p:sp>
       <p:sp>
         <p:nvSpPr>
-          <p:cNvPr id="16" name="Text 14"/>
+          <p:cNvPr id="18" name="Text 16"/>
           <p:cNvSpPr/>
           <p:nvPr/>
         </p:nvSpPr>
@@ -1384,7 +1462,7 @@
       </p:sp>
       <p:sp>
         <p:nvSpPr>
-          <p:cNvPr id="17" name="Shape 15"/>
+          <p:cNvPr id="19" name="Shape 17"/>
           <p:cNvSpPr/>
           <p:nvPr/>
         </p:nvSpPr>
@@ -1411,7 +1489,7 @@
       </p:sp>
       <p:sp>
         <p:nvSpPr>
-          <p:cNvPr id="18" name="Shape 16"/>
+          <p:cNvPr id="20" name="Shape 18"/>
           <p:cNvSpPr/>
           <p:nvPr/>
         </p:nvSpPr>
@@ -1436,7 +1514,7 @@
       </p:sp>
       <p:sp>
         <p:nvSpPr>
-          <p:cNvPr id="19" name="Text 17"/>
+          <p:cNvPr id="21" name="Text 19"/>
           <p:cNvSpPr/>
           <p:nvPr/>
         </p:nvSpPr>
@@ -1475,7 +1553,7 @@
       </p:sp>
       <p:sp>
         <p:nvSpPr>
-          <p:cNvPr id="20" name="Text 18"/>
+          <p:cNvPr id="22" name="Text 20"/>
           <p:cNvSpPr/>
           <p:nvPr/>
         </p:nvSpPr>
@@ -1514,7 +1592,7 @@
       </p:sp>
       <p:sp>
         <p:nvSpPr>
-          <p:cNvPr id="21" name="Text 19"/>
+          <p:cNvPr id="23" name="Text 21"/>
           <p:cNvSpPr/>
           <p:nvPr/>
         </p:nvSpPr>
@@ -1553,7 +1631,7 @@
       </p:sp>
       <p:sp>
         <p:nvSpPr>
-          <p:cNvPr id="22" name="Text 20"/>
+          <p:cNvPr id="24" name="Text 22"/>
           <p:cNvSpPr/>
           <p:nvPr/>
         </p:nvSpPr>

</xml_diff>